<commit_message>
A paragraph wrapping onto a last line of one or two words is a warning quoting that line, unless a line break the writer typed starts it; the fixtures are reworded to check clean and their stored decks exported again
Co-Authored-By: Claude Opus 5.5 <noreply@anthropic.com>
</commit_message>
<xml_diff>
--- a/src/Pintura.Tests/fixtures/pptx/default-theme.pptx
+++ b/src/Pintura.Tests/fixtures/pptx/default-theme.pptx
@@ -5,12 +5,12 @@
     <p:sldMasterId id="2147483648" r:id="rId1"/>
   </p:sldMasterIdLst>
   <p:sldIdLst>
-    <p:sldId id="257" r:id="Rede929e31373429e"/>
-    <p:sldId id="258" r:id="R7609ee0fda3543b9"/>
-    <p:sldId id="259" r:id="R9b03bb61f13d4eca"/>
-    <p:sldId id="260" r:id="Rff1f3bd5091a4faa"/>
-    <p:sldId id="261" r:id="R4fcec321fc4d4473"/>
-    <p:sldId id="262" r:id="Rc47144963c8f4b55"/>
+    <p:sldId id="257" r:id="R6f2b14a50233405e"/>
+    <p:sldId id="258" r:id="R1a74081968284f03"/>
+    <p:sldId id="259" r:id="R15120315ce104d6b"/>
+    <p:sldId id="260" r:id="R198d32a3b8554258"/>
+    <p:sldId id="261" r:id="Ra9d6da514b7a4d54"/>
+    <p:sldId id="262" r:id="Rc772f67106e046d4"/>
   </p:sldIdLst>
   <p:sldSz cx="12192000" cy="6858000"/>
   <p:notesSz cx="6858000" cy="9144000"/>
@@ -112,12 +112,12 @@
   <p:extLst>
     <p:ext uri="{521415D9-36F7-43E2-AB2F-B90AF26B5E84}">
       <p14:sectionLst xmlns:p14="http://schemas.microsoft.com/office/powerpoint/2010/main">
-        <p14:section name="Default Section" id="{1FF75EB3-ABB8-4CD1-8A32-0256EBB70A98}">
+        <p14:section name="Default Section" id="{55B12989-43EE-4390-9368-9C7289A90573}">
           <p14:sldIdLst>
             <p14:sldId id="257"/>
           </p14:sldIdLst>
         </p14:section>
-        <p14:section name="Full-year results" id="{0A83E073-CFC9-44CC-9410-B8AED0B1D8BD}">
+        <p14:section name="Full-year results" id="{0CB91B10-E7B7-499B-9E12-956B584BCF0C}">
           <p14:sldIdLst>
             <p14:sldId id="258"/>
             <p14:sldId id="259"/>
@@ -125,7 +125,7 @@
             <p14:sldId id="261"/>
           </p14:sldIdLst>
         </p14:section>
-        <p14:section name="First half of 2026" id="{C9E2DDCA-2852-425A-91A5-4E3F79BA8FA0}">
+        <p14:section name="First half of 2026" id="{B63BF00F-C7C4-475D-ACF1-BD16B1077771}">
           <p14:sldIdLst>
             <p14:sldId id="262"/>
           </p14:sldIdLst>
@@ -232,7 +232,7 @@
             </a:lvl1pPr>
           </a:lstStyle>
           <a:p>
-            <a:fld id="{AC5A1E1C-B78F-4B5E-98DD-80D6E7CE0055}" type="slidenum">
+            <a:fld id="{A7EA44E2-2FED-4BAE-8B65-428F44AFA99C}" type="slidenum">
               <a:rPr lang="en-US"/>
               <a:t>‹#›</a:t>
             </a:fld>
@@ -448,7 +448,7 @@
             </a:lvl1pPr>
           </a:lstStyle>
           <a:p>
-            <a:fld id="{C20A36E9-3485-421E-9543-C97008690941}" type="slidenum">
+            <a:fld id="{DB34F352-9F73-4503-A76A-E540AC49663A}" type="slidenum">
               <a:rPr lang="en-US"/>
               <a:t>‹#›</a:t>
             </a:fld>
@@ -901,9 +901,9 @@
   </p:cSld>
   <p:clrMap bg1="lt1" tx1="dk1" bg2="lt2" tx2="dk2" accent1="accent1" accent2="accent2" accent3="accent3" accent4="accent4" accent5="accent5" accent6="accent6" hlink="hlink" folHlink="folHlink"/>
   <p:sldLayoutIdLst>
-    <p:sldLayoutId id="2147483650" r:id="R0a643ba796b34f2d"/>
-    <p:sldLayoutId id="2147483651" r:id="R478e205a42a64618"/>
-    <p:sldLayoutId id="2147483652" r:id="R68b529be597b40bd"/>
+    <p:sldLayoutId id="2147483650" r:id="R1a37092aafe8443c"/>
+    <p:sldLayoutId id="2147483651" r:id="R143323e99d9c4b16"/>
+    <p:sldLayoutId id="2147483652" r:id="R6b1e10f89e9141fc"/>
   </p:sldLayoutIdLst>
   <p:txStyles>
     <p:titleStyle>
@@ -1593,7 +1593,7 @@
     <c:plotVisOnly val="1"/>
     <c:dispBlanksAs val="gap"/>
   </c:chart>
-  <c:externalData xmlns:r="http://schemas.openxmlformats.org/officeDocument/2006/relationships" r:id="R6c583b100cde4ccf">
+  <c:externalData xmlns:r="http://schemas.openxmlformats.org/officeDocument/2006/relationships" r:id="Rb8fdea9def7d43d4">
     <c:autoUpdate val="0"/>
   </c:externalData>
 </c:chartSpace>
@@ -1801,7 +1801,7 @@
             </a:lvl1pPr>
           </a:lstStyle>
           <a:p xmlns:a="http://schemas.openxmlformats.org/drawingml/2006/main">
-            <a:fld id="{C20A36E9-3485-421E-9543-C97008690941}" type="slidenum">
+            <a:fld id="{DB34F352-9F73-4503-A76A-E540AC49663A}" type="slidenum">
               <a:rPr lang="en-US"/>
               <a:t>‹#›</a:t>
             </a:fld>
@@ -4097,7 +4097,7 @@
             </a:lvl1pPr>
           </a:lstStyle>
           <a:p xmlns:a="http://schemas.openxmlformats.org/drawingml/2006/main">
-            <a:fld id="{AC5A1E1C-B78F-4B5E-98DD-80D6E7CE0055}" type="slidenum">
+            <a:fld id="{A7EA44E2-2FED-4BAE-8B65-428F44AFA99C}" type="slidenum">
               <a:rPr lang="en-US"/>
               <a:t>‹#›</a:t>
             </a:fld>
@@ -4165,7 +4165,7 @@
         </p:xfrm>
         <a:graphic>
           <a:graphicData uri="http://schemas.openxmlformats.org/drawingml/2006/chart">
-            <c:chart xmlns:r="http://schemas.openxmlformats.org/officeDocument/2006/relationships" xmlns:c="http://schemas.openxmlformats.org/drawingml/2006/chart" r:id="R51b75e527c85448e"/>
+            <c:chart xmlns:r="http://schemas.openxmlformats.org/officeDocument/2006/relationships" xmlns:c="http://schemas.openxmlformats.org/drawingml/2006/chart" r:id="R43362ae299084175"/>
           </a:graphicData>
         </a:graphic>
       </p:graphicFrame>
@@ -4211,7 +4211,7 @@
                 </a:solidFill>
                 <a:latin typeface="+mn-lt"/>
               </a:rPr>
-              <a:t>Adjusted EBITDA of $6.6B in 2025, from $3.8B in 2023</a:t>
+              <a:t>Adjusted EBITDA of $6.6B in 2025, up from $3.8B in 2023</a:t>
             </a:r>
             <a:endParaRPr sz="1800" b="1" i="0" u="none">
               <a:solidFill>
@@ -4446,7 +4446,7 @@
             </a:lvl1pPr>
           </a:lstStyle>
           <a:p xmlns:a="http://schemas.openxmlformats.org/drawingml/2006/main">
-            <a:fld id="{AC5A1E1C-B78F-4B5E-98DD-80D6E7CE0055}" type="slidenum">
+            <a:fld id="{A7EA44E2-2FED-4BAE-8B65-428F44AFA99C}" type="slidenum">
               <a:rPr lang="en-US"/>
               <a:t>‹#›</a:t>
             </a:fld>
@@ -5043,7 +5043,7 @@
             </a:lvl1pPr>
           </a:lstStyle>
           <a:p xmlns:a="http://schemas.openxmlformats.org/drawingml/2006/main">
-            <a:fld id="{AC5A1E1C-B78F-4B5E-98DD-80D6E7CE0055}" type="slidenum">
+            <a:fld id="{A7EA44E2-2FED-4BAE-8B65-428F44AFA99C}" type="slidenum">
               <a:rPr lang="en-US"/>
               <a:t>‹#›</a:t>
             </a:fld>
@@ -5574,7 +5574,7 @@
             </a:lvl1pPr>
           </a:lstStyle>
           <a:p xmlns:a="http://schemas.openxmlformats.org/drawingml/2006/main">
-            <a:fld id="{AC5A1E1C-B78F-4B5E-98DD-80D6E7CE0055}" type="slidenum">
+            <a:fld id="{A7EA44E2-2FED-4BAE-8B65-428F44AFA99C}" type="slidenum">
               <a:rPr lang="en-US"/>
               <a:t>‹#›</a:t>
             </a:fld>

</xml_diff>